<commit_message>
Remove em/en dashes across submitted docs; add team names to deck + discussion; trim verdict bullet
Co-Authored-By: Claude Opus 4.8 (1M context) <noreply@anthropic.com>
</commit_message>
<xml_diff>
--- a/InstiGuard_Presentation.pptx
+++ b/InstiGuard_Presentation.pptx
@@ -3245,7 +3245,46 @@
                 </a:solidFill>
                 <a:latin typeface="Calibri"/>
               </a:rPr>
-              <a:t>Evaluation, not training — is this model safe enough to deploy?</a:t>
+              <a:t>Evaluation, not training: is this model safe enough to deploy?</a:t>
+            </a:r>
+          </a:p>
+        </p:txBody>
+      </p:sp>
+      <p:sp>
+        <p:nvSpPr>
+          <p:cNvPr id="5" name="TextBox 4"/>
+          <p:cNvSpPr txBox="1"/>
+          <p:nvPr/>
+        </p:nvSpPr>
+        <p:spPr>
+          <a:xfrm>
+            <a:off x="822960" y="5806440"/>
+            <a:ext cx="10515600" cy="640080"/>
+          </a:xfrm>
+          <a:prstGeom prst="rect">
+            <a:avLst/>
+          </a:prstGeom>
+          <a:noFill/>
+        </p:spPr>
+        <p:txBody>
+          <a:bodyPr wrap="square">
+            <a:spAutoFit/>
+          </a:bodyPr>
+          <a:lstStyle/>
+          <a:p>
+            <a:pPr algn="l">
+              <a:spcAft>
+                <a:spcPts val="600"/>
+              </a:spcAft>
+            </a:pPr>
+            <a:r>
+              <a:rPr sz="1500" b="1">
+                <a:solidFill>
+                  <a:srgbClr val="FFFFFF"/>
+                </a:solidFill>
+                <a:latin typeface="Calibri"/>
+              </a:rPr>
+              <a:t>Arnav Jain · Shawn Ding · Tianyin Mao · Rameez Ali · Ethan Meidinger</a:t>
             </a:r>
           </a:p>
         </p:txBody>
@@ -3550,7 +3589,7 @@
                 </a:solidFill>
                 <a:latin typeface="Calibri"/>
               </a:rPr>
-              <a:t>What We Built — a 5-Metric Safety Scorecard</a:t>
+              <a:t>What We Built: a 5-Metric Safety Scorecard</a:t>
             </a:r>
           </a:p>
         </p:txBody>
@@ -3589,7 +3628,7 @@
                 </a:solidFill>
                 <a:latin typeface="Calibri"/>
               </a:rPr>
-              <a:t>•  1  Faithfulness / hallucination — fabricated figures are a regulatory liability</a:t>
+              <a:t>•  1  Faithfulness / hallucination: fabricated figures are a regulatory liability</a:t>
             </a:r>
           </a:p>
           <a:p>
@@ -3605,7 +3644,7 @@
                 </a:solidFill>
                 <a:latin typeface="Calibri"/>
               </a:rPr>
-              <a:t>•  2  PII leakage — emitting SSNs / accounts / salaries violates GDPR / HIPAA / SOX</a:t>
+              <a:t>•  2  PII leakage: emitting SSNs / accounts / salaries violates GDPR / HIPAA / SOX</a:t>
             </a:r>
           </a:p>
           <a:p>
@@ -3621,7 +3660,7 @@
                 </a:solidFill>
                 <a:latin typeface="Calibri"/>
               </a:rPr>
-              <a:t>•  3  Steerability — does it honor a 'never disclose' system rule under pressure?</a:t>
+              <a:t>•  3  Steerability: does it honor a 'never disclose' system rule under pressure?</a:t>
             </a:r>
           </a:p>
           <a:p>
@@ -3637,7 +3676,7 @@
                 </a:solidFill>
                 <a:latin typeface="Calibri"/>
               </a:rPr>
-              <a:t>•  4  Cross-lingual safety gap — do guardrails survive in Spanish and low-resource Swahili?</a:t>
+              <a:t>•  4  Cross-lingual safety gap: do guardrails survive in Spanish and low-resource Swahili?</a:t>
             </a:r>
           </a:p>
           <a:p>
@@ -3653,7 +3692,7 @@
                 </a:solidFill>
                 <a:latin typeface="Calibri"/>
               </a:rPr>
-              <a:t>•  5  [BONUS] Context-saturation constraint decay — does it drop a rule as context grows?</a:t>
+              <a:t>•  5  [BONUS] Context-saturation constraint decay: does it drop a rule as context grows?</a:t>
             </a:r>
           </a:p>
           <a:p>
@@ -3873,7 +3912,7 @@
                 </a:solidFill>
                 <a:latin typeface="Calibri"/>
               </a:rPr>
-              <a:t>•  Ran on a single 24GB GPU (Rivanna) — the hardware limit becomes part of the story.</a:t>
+              <a:t>•  Ran on a single 24GB GPU (Rivanna): the hardware limit becomes part of the story.</a:t>
             </a:r>
           </a:p>
         </p:txBody>
@@ -3974,7 +4013,7 @@
                 </a:solidFill>
                 <a:latin typeface="Calibri"/>
               </a:rPr>
-              <a:t>Result 1 — Instruction Tuning Is the Safety Lever</a:t>
+              <a:t>Result 1: Instruction Tuning Is the Safety Lever</a:t>
             </a:r>
           </a:p>
         </p:txBody>
@@ -4303,7 +4342,7 @@
                 </a:solidFill>
                 <a:latin typeface="Calibri"/>
               </a:rPr>
-              <a:t>Result 2 — Cross-Lingual Safety Gap</a:t>
+              <a:t>Result 2: Cross-Lingual Safety Gap</a:t>
             </a:r>
           </a:p>
         </p:txBody>
@@ -4515,7 +4554,7 @@
                 </a:solidFill>
                 <a:latin typeface="Calibri"/>
               </a:rPr>
-              <a:t>•  An honest null result — we report it rather than overclaim.</a:t>
+              <a:t>•  An honest null result: we report it rather than overclaim.</a:t>
             </a:r>
           </a:p>
         </p:txBody>
@@ -4616,7 +4655,7 @@
                 </a:solidFill>
                 <a:latin typeface="Calibri"/>
               </a:rPr>
-              <a:t>Key Insight — The Judges Disagree</a:t>
+              <a:t>Key Insight: The Judges Disagree</a:t>
             </a:r>
           </a:p>
         </p:txBody>
@@ -4679,7 +4718,7 @@
                 </a:solidFill>
                 <a:latin typeface="Calibri"/>
               </a:rPr>
-              <a:t>mean P(fail) per judge — LLM-as-judge is a noisy instrument</a:t>
+              <a:t>mean P(fail) per judge: LLM-as-judge is a noisy instrument</a:t>
             </a:r>
           </a:p>
         </p:txBody>
@@ -5125,7 +5164,7 @@
                 </a:solidFill>
                 <a:latin typeface="Calibri"/>
               </a:rPr>
-              <a:t>•  At ~40k tokens the 24GB GPU OOMs — a hardware ceiling, not proof of no decay.</a:t>
+              <a:t>•  At ~40k tokens the 24GB GPU OOMs: a hardware ceiling, not proof of no decay.</a:t>
             </a:r>
           </a:p>
           <a:p>
@@ -5362,22 +5401,6 @@
                 <a:latin typeface="Calibri"/>
               </a:rPr>
               <a:t>The deeper lesson: a safety scorecard is only as trustworthy as its judges.</a:t>
-            </a:r>
-          </a:p>
-          <a:p>
-            <a:pPr algn="l">
-              <a:spcAft>
-                <a:spcPts val="1000"/>
-              </a:spcAft>
-            </a:pPr>
-            <a:r>
-              <a:rPr sz="2000" b="0">
-                <a:solidFill>
-                  <a:srgbClr val="444444"/>
-                </a:solidFill>
-                <a:latin typeface="Calibri"/>
-              </a:rPr>
-              <a:t>•  Being honest about that — and building a panel to expose it — is the whole point.</a:t>
             </a:r>
           </a:p>
         </p:txBody>

</xml_diff>